<commit_message>
fix: normalize all 40 lecture schemas and compact HTML blocks for VitePress SFC compiler
</commit_message>
<xml_diff>
--- a/docs/public/downloads/劉松博_公司治理30講_無雜訊顧問簡報_精華16頁.pptx
+++ b/docs/public/downloads/劉松博_公司治理30講_無雜訊顧問簡報_精華16頁.pptx
@@ -659,7 +659,7 @@
           </a:p>
           <a:p>
             <a:r>
-              <a:t>🔗【跨講因果鏈】{'prev': '承接第 16 講：釐清董事長與 CEO 的職權後，深入剖析大股東（老闆）與職業經理人（CEO）衝突的底層成因', 'current': '揭示「委託代理問題」與「過高心理所有權」兩大衝突根源，並確立經理治理的「監控、選人、激勵」三支柱（其中監控沿用第二模組）', 'next': '觸發第 18 講：既然監控機制已在第二模組講過，接下來重點看第二個抓手——到底怎麼「選人」？（何為職業化）'}</a:t>
+              <a:t>🔗【跨講因果鏈】【承上】承接第 16 講：釐清董事長與 CEO 的職權後，深入剖析大股東（老闆）與職業經理人（CEO）衝突的底層成因 ➔ 【本講核心】揭示「委託代理問題」與「過高心理所有權」兩大衝突根源，並確立經理治理的「監控、選人、激勵」三支柱（其中監控沿用第二模組） ➔ 【啟下】觸發第 18 講：既然監控機制已在第二模組講過，接下來重點看第二個抓手——到底怎麼「選人」？（何為職業化）</a:t>
             </a:r>
           </a:p>
         </p:txBody>
@@ -765,7 +765,7 @@
           </a:p>
           <a:p>
             <a:r>
-              <a:t>🔗【跨講因果鏈】{'prev': '承接第 16–20 講：完成一般商業公司的經理治理後，檢視特殊產權結構之一——國有企業的治理難題', 'current': '提出「分類改革」與「行政治理 vs. 公司治理分離」原則', 'next': '觸發第 22 講：國企的難題是「行政干預公司」，而民營企業最大的特殊產權難題則是「家族情感干預公司」——家族企業如何打破富不過三代？'}</a:t>
+              <a:t>🔗【跨講因果鏈】【承上】承接第 16–20 講：完成一般商業公司的經理治理後，檢視特殊產權結構之一——國有企業的治理難題 ➔ 【本講核心】提出「分類改革」與「行政治理 vs. 公司治理分離」原則 ➔ 【啟下】觸發第 22 講：國企的難題是「行政干預公司」，而民營企業最大的特殊產權難題則是「家族情感干預公司」——家族企業如何打破富不過三代？</a:t>
             </a:r>
           </a:p>
         </p:txBody>
@@ -871,7 +871,7 @@
           </a:p>
           <a:p>
             <a:r>
-              <a:t>🔗【跨講因果鏈】{'prev': '承接第 23 講：萬科與南玻案例暴露了「純粹資本股東至上」可能傷害管理團隊與企業長期價值', 'current': '對比「股東至上」與「利害關係人理論」，點出後者雖具道德高度卻面臨「多元目標無法考核」的操作困境', 'next': '觸發第 25 講：既然不能籠統地說「對所有人負責」，那如果一定要排一個先後順序，誰應該排在最前面？（客戶優先！）'}</a:t>
+              <a:t>🔗【跨講因果鏈】【承上】承接第 23 講：萬科與南玻案例暴露了「純粹資本股東至上」可能傷害管理團隊與企業長期價值 ➔ 【本講核心】對比「股東至上」與「利害關係人理論」，點出後者雖具道德高度卻面臨「多元目標無法考核」的操作困境 ➔ 【啟下】觸發第 25 講：既然不能籠統地說「對所有人負責」，那如果一定要排一個先後順序，誰應該排在最前面？（客戶優先！）</a:t>
             </a:r>
           </a:p>
         </p:txBody>
@@ -977,7 +977,7 @@
           </a:p>
           <a:p>
             <a:r>
-              <a:t>🔗【跨講因果鏈】{'prev': '承接第 24–25 講：在探討完利害關係人與客戶優先後，實地檢視全球最著名的「利害關係人治理標竿」——德國模式', 'current': '拆解德國第一大特色「垂直監事會」的制度優勢與德意志銀行暴露出的獨立性失靈', 'next': '觸發第 27 講：德國監事會裡還有一個令全球老闆瞠目結舌的規定——「一半席位必須留給員工代表」！這就是下一講的「員工共決制」。'}</a:t>
+              <a:t>🔗【跨講因果鏈】【承上】承接第 24–25 講：在探討完利害關係人與客戶優先後，實地檢視全球最著名的「利害關係人治理標竿」——德國模式 ➔ 【本講核心】拆解德國第一大特色「垂直監事會」的制度優勢與德意志銀行暴露出的獨立性失靈 ➔ 【啟下】觸發第 27 講：德國監事會裡還有一個令全球老闆瞠目結舌的規定——「一半席位必須留給員工代表」！這就是下一講的「員工共決制」。</a:t>
             </a:r>
           </a:p>
         </p:txBody>
@@ -1083,7 +1083,7 @@
           </a:p>
           <a:p>
             <a:r>
-              <a:t>🔗【跨講因果鏈】{'prev': '承接第 17–20 講與第 25 講：當傳統監督與激勵仍無法解決經理人「包贏不包輸」，且第 25 講留下的「誰是權力中心」亟待解答', 'current': '提出「事業合夥人制（強制跟投＋風險共擔）」，完成從「控制經理人」到「激活合夥人並共擔風險」的治理升維', 'next': '觸發第 30 講：當公司有了幾十上百個事業合夥人、權力下放了，靠什麼防止他們各自為政、山頭林立？（企業軟治理：價值觀落地！）'}</a:t>
+              <a:t>🔗【跨講因果鏈】【承上】承接第 17–20 講與第 25 講：當傳統監督與激勵仍無法解決經理人「包贏不包輸」，且第 25 講留下的「誰是權力中心」亟待解答 ➔ 【本講核心】提出「事業合夥人制（強制跟投＋風險共擔）」，完成從「控制經理人」到「激活合夥人並共擔風險」的治理升維 ➔ 【啟下】觸發第 30 講：當公司有了幾十上百個事業合夥人、權力下放了，靠什麼防止他們各自為政、山頭林立？（企業軟治理：價值觀落地！）</a:t>
             </a:r>
           </a:p>
         </p:txBody>
@@ -1189,7 +1189,7 @@
           </a:p>
           <a:p>
             <a:r>
-              <a:t>🔗【跨講因果鏈】{'prev': '承接第 31 講：將治理下沉從「分股權（全員持股）」推向極致——「分經營權與創業權（內部裂變創業）」', 'current': '揭示內部創業受限於「企業家精神稀缺」與「大公司科層慣性」，區分創新特區與複製裂變兩條路徑', 'next': '觸發第 33 講：既然公司內部的企業家精神終究有限，如果我們走出公司圍牆，把外面的創業者連結起來呢？這就升維到了「生態型組織與生態治理」！'}</a:t>
+              <a:t>🔗【跨講因果鏈】【承上】承接第 31 講：將治理下沉從「分股權（全員持股）」推向極致——「分經營權與創業權（內部裂變創業）」 ➔ 【本講核心】揭示內部創業受限於「企業家精神稀缺」與「大公司科層慣性」，區分創新特區與複製裂變兩條路徑 ➔ 【啟下】觸發第 33 講：既然公司內部的企業家精神終究有限，如果我們走出公司圍牆，把外面的創業者連結起來呢？這就升維到了「生態型組織與生態治理」！</a:t>
             </a:r>
           </a:p>
         </p:txBody>
@@ -1295,7 +1295,7 @@
           </a:p>
           <a:p>
             <a:r>
-              <a:t>🔗【跨講因果鏈】{'prev': '全課起點：打破「只看業績與管理技巧」的認知盲區', 'current': '確立「股東 vs. 經理人」與「權力 vs. 利益」二維座標系', 'next': '接續第 01 講：探究這套規則的載體——為什麼人類有了企業，還要發明「公司」？'}</a:t>
+              <a:t>🔗【跨講因果鏈】【承上】全課起點：打破「只看業績與管理技巧」的認知盲區 ➔ 【本講核心】確立「股東 vs. 經理人」與「權力 vs. 利益」二維座標系 ➔ 【啟下】接續第 01 講：探究這套規則的載體——為什麼人類有了企業，還要發明「公司」？</a:t>
             </a:r>
           </a:p>
         </p:txBody>
@@ -1401,7 +1401,7 @@
           </a:p>
           <a:p>
             <a:r>
-              <a:t>🔗【跨講因果鏈】{'prev': '承接第 00 講：要談公司治理，先界定「公司」與其他企業型態的法律與經濟邊界', 'current': '揭示「有限責任＋獨立法人」如何創造龐大集資力與永續性，同時要求公私財產嚴格分離', 'next': '觸發第 02 講：正因股東眾多且只負有限責任，衍生出「兩權分離代理問題」與「大股東濫權」兩大先天缺陷！'}</a:t>
+              <a:t>🔗【跨講因果鏈】【承上】承接第 00 講：要談公司治理，先界定「公司」與其他企業型態的法律與經濟邊界 ➔ 【本講核心】揭示「有限責任＋獨立法人」如何創造龐大集資力與永續性，同時要求公私財產嚴格分離 ➔ 【啟下】觸發第 02 講：正因股東眾多且只負有限責任，衍生出「兩權分離代理問題」與「大股東濫權」兩大先天缺陷！</a:t>
             </a:r>
           </a:p>
         </p:txBody>
@@ -1507,7 +1507,7 @@
           </a:p>
           <a:p>
             <a:r>
-              <a:t>🔗【跨講因果鏈】{'prev': '承接第 02 講：為了解決代理問題與利益衝突，必須找到維繫組織合作的底層力量——信任', 'current': '完成第一模組認知建構：公司治理即是以「制度信任」彌補「人際信任」隨規模擴張而衰減的工程', 'next': '進入第二模組（第 04 講）：正式拆解股東治理的核心武器——股權本質上到底是什麼權？'}</a:t>
+              <a:t>🔗【跨講因果鏈】【承上】承接第 02 講：為了解決代理問題與利益衝突，必須找到維繫組織合作的底層力量——信任 ➔ 【本講核心】完成第一模組認知建構：公司治理即是以「制度信任」彌補「人際信任」隨規模擴張而衰減的工程 ➔ 【啟下】進入第二模組（第 04 講）：正式拆解股東治理的核心武器——股權本質上到底是什麼權？</a:t>
             </a:r>
           </a:p>
         </p:txBody>
@@ -1613,7 +1613,7 @@
           </a:p>
           <a:p>
             <a:r>
-              <a:t>🔗【跨講因果鏈】{'prev': '承接第 06 講：初始股權架構設好後，面對外部融資稀釋的動態挑戰', 'current': '建構非上市階段四大控制權防禦工具（股權、資源、GP/LP 架構、章程協議）', 'next': '觸發第 08 講：當公司準備上市、多數交易所不允許隨意修改章程時，如何用「同股不同權（AB 股）」繼續保住控制權？'}</a:t>
+              <a:t>🔗【跨講因果鏈】【承上】承接第 06 講：初始股權架構設好後，面對外部融資稀釋的動態挑戰 ➔ 【本講核心】建構非上市階段四大控制權防禦工具（股權、資源、GP/LP 架構、章程協議） ➔ 【啟下】觸發第 08 講：當公司準備上市、多數交易所不允許隨意修改章程時，如何用「同股不同權（AB 股）」繼續保住控制權？</a:t>
             </a:r>
           </a:p>
         </p:txBody>
@@ -1719,7 +1719,7 @@
           </a:p>
           <a:p>
             <a:r>
-              <a:t>🔗【跨講因果鏈】{'prev': '承接第 07–08 講：當創始人透過架構與 AB 股取得絕對控制權後，必然引發權力失控的副作用', 'current': '提出「企業家悖論」與「CEO 五季節模型」，完成從「保護控制權」向「制衡控制權」的邏輯轉折', 'next': '觸發第 10–15 講：既然要制約掌權者，有哪些具體工具？首先從最溫和卻最有力量的第 10 講「透明化」開始！'}</a:t>
+              <a:t>🔗【跨講因果鏈】【承上】承接第 07–08 講：當創始人透過架構與 AB 股取得絕對控制權後，必然引發權力失控的副作用 ➔ 【本講核心】提出「企業家悖論」與「CEO 五季節模型」，完成從「保護控制權」向「制衡控制權」的邏輯轉折 ➔ 【啟下】觸發第 10–15 講：既然要制約掌權者，有哪些具體工具？首先從最溫和卻最有力量的第 10 講「透明化」開始！</a:t>
             </a:r>
           </a:p>
         </p:txBody>
@@ -1825,7 +1825,7 @@
           </a:p>
           <a:p>
             <a:r>
-              <a:t>🔗【跨講因果鏈】{'prev': '承接第 09 講：面對「企業家悖論」，需要尋找制約大股東與核心領導人的制度工具', 'current': '提出第一道溫和而強大的制約工具——「透明化」，揭示上市在融資之外的治理升級價值', 'next': '觸發第 11 講：既然透明與上市有這麼多好處，為什麼老乾媽、華為、西貝等無數企業家在「上不上市」問題上反覆糾結甚至被打臉？'}</a:t>
+              <a:t>🔗【跨講因果鏈】【承上】承接第 09 講：面對「企業家悖論」，需要尋找制約大股東與核心領導人的制度工具 ➔ 【本講核心】提出第一道溫和而強大的制約工具——「透明化」，揭示上市在融資之外的治理升級價值 ➔ 【啟下】觸發第 11 講：既然透明與上市有這麼多好處，為什麼老乾媽、華為、西貝等無數企業家在「上不上市」問題上反覆糾結甚至被打臉？</a:t>
             </a:r>
           </a:p>
         </p:txBody>
@@ -1931,7 +1931,7 @@
           </a:p>
           <a:p>
             <a:r>
-              <a:t>🔗【跨講因果鏈】{'prev': '承接第 10 講：討論完上市帶來的「透明化溢價」正面效益，本講完整拆解上市的正反兩面與動態取捨', 'current': '建立「不因上市與否論成敗、隨環境變化動態調整」的情境決策框架', 'next': '觸發第 12 講：無論上市與否，當控股大股東權力過大時，公司內部該如何制衡控股股東？'}</a:t>
+              <a:t>🔗【跨講因果鏈】【承上】承接第 10 講：討論完上市帶來的「透明化溢價」正面效益，本講完整拆解上市的正反兩面與動態取捨 ➔ 【本講核心】建立「不因上市與否論成敗、隨環境變化動態調整」的情境決策框架 ➔ 【啟下】觸發第 12 講：無論上市與否，當控股大股東權力過大時，公司內部該如何制衡控股股東？</a:t>
             </a:r>
           </a:p>
         </p:txBody>
@@ -2037,7 +2037,7 @@
           </a:p>
           <a:p>
             <a:r>
-              <a:t>🔗【跨講因果鏈】{'prev': '承接第 15 講：從第二模組最後的「董事會」，自然過渡到第三模組「經理治理」的最高首長——CEO', 'current': '釐清董事長（集體會議主持）與 CEO（個人行政指揮）的制度邊界，建立兩職分合的情境權變觀', 'next': '觸發第 17 講：當老闆（董事長／大股東）請了職業經理人（CEO）來管公司，為什麼兩人總是吵架甚至拔刀相向？'}</a:t>
+              <a:t>🔗【跨講因果鏈】【承上】承接第 15 講：從第二模組最後的「董事會」，自然過渡到第三模組「經理治理」的最高首長——CEO ➔ 【本講核心】釐清董事長（集體會議主持）與 CEO（個人行政指揮）的制度邊界，建立兩職分合的情境權變觀 ➔ 【啟下】觸發第 17 講：當老闆（董事長／大股東）請了職業經理人（CEO）來管公司，為什麼兩人總是吵架甚至拔刀相向？</a:t>
             </a:r>
           </a:p>
         </p:txBody>
@@ -6050,7 +6050,7 @@
                 </a:solidFill>
                 <a:latin typeface="Microsoft JhengHei"/>
               </a:rPr>
-              <a:t>模式 A</a:t>
+              <a:t>② 角色 A：董事長 (Chairman of the Board)</a:t>
             </a:r>
           </a:p>
         </p:txBody>
@@ -6171,7 +6171,7 @@
                 </a:solidFill>
                 <a:latin typeface="Microsoft JhengHei"/>
               </a:rPr>
-              <a:t>模式 B</a:t>
+              <a:t>② 角色 B：首席執行官 (CEO / 總經理)</a:t>
             </a:r>
           </a:p>
         </p:txBody>
@@ -6248,6 +6248,15 @@
                 <a:spcPct val="118000"/>
               </a:lnSpc>
             </a:pPr>
+            <a:r>
+              <a:rPr sz="919" b="1">
+                <a:solidFill>
+                  <a:srgbClr val="004B2B"/>
+                </a:solidFill>
+                <a:latin typeface="Microsoft JhengHei"/>
+              </a:rPr>
+              <a:t>權力來源與性質</a:t>
+            </a:r>
           </a:p>
         </p:txBody>
       </p:sp>
@@ -6323,6 +6332,15 @@
                 <a:spcPct val="114000"/>
               </a:lnSpc>
             </a:pPr>
+            <a:r>
+              <a:rPr sz="880" b="0">
+                <a:solidFill>
+                  <a:srgbClr val="1A2E23"/>
+                </a:solidFill>
+                <a:latin typeface="Microsoft JhengHei"/>
+              </a:rPr>
+              <a:t>③ 董事會召集人：採「一人一票、集體決策」，法律上董事長個人並無直接行政指揮權</a:t>
+            </a:r>
           </a:p>
         </p:txBody>
       </p:sp>
@@ -6437,6 +6455,15 @@
                 <a:spcPct val="114000"/>
               </a:lnSpc>
             </a:pPr>
+            <a:r>
+              <a:rPr sz="880" b="0">
+                <a:solidFill>
+                  <a:srgbClr val="1A2E23"/>
+                </a:solidFill>
+                <a:latin typeface="Microsoft JhengHei"/>
+              </a:rPr>
+              <a:t>③ 最高行政首長：採「首長負責制、個人拍板」，全權指揮日常營運、副總與各部門</a:t>
+            </a:r>
           </a:p>
         </p:txBody>
       </p:sp>
@@ -6512,6 +6539,15 @@
                 <a:spcPct val="118000"/>
               </a:lnSpc>
             </a:pPr>
+            <a:r>
+              <a:rPr sz="919" b="1">
+                <a:solidFill>
+                  <a:srgbClr val="004B2B"/>
+                </a:solidFill>
+                <a:latin typeface="Microsoft JhengHei"/>
+              </a:rPr>
+              <a:t>為什麼常覺董事長大？</a:t>
+            </a:r>
           </a:p>
         </p:txBody>
       </p:sp>
@@ -6587,6 +6623,15 @@
                 <a:spcPct val="114000"/>
               </a:lnSpc>
             </a:pPr>
+            <a:r>
+              <a:rPr sz="880" b="0">
+                <a:solidFill>
+                  <a:srgbClr val="1A2E23"/>
+                </a:solidFill>
+                <a:latin typeface="Microsoft JhengHei"/>
+              </a:rPr>
+              <a:t>因為亞洲企業董事長通常由「控股大股東／創始人」兼任，大的是他背後的【股東身分】而非董事長頭銜</a:t>
+            </a:r>
           </a:p>
         </p:txBody>
       </p:sp>
@@ -6701,6 +6746,15 @@
                 <a:spcPct val="114000"/>
               </a:lnSpc>
             </a:pPr>
+            <a:r>
+              <a:rPr sz="880" b="0">
+                <a:solidFill>
+                  <a:srgbClr val="1A2E23"/>
+                </a:solidFill>
+                <a:latin typeface="Microsoft JhengHei"/>
+              </a:rPr>
+              <a:t>在股權分散的美國企業（如蘋果、GE），CEO 往往才是實權核心，但仍受董事會集體任免</a:t>
+            </a:r>
           </a:p>
         </p:txBody>
       </p:sp>
@@ -6776,6 +6830,15 @@
                 <a:spcPct val="118000"/>
               </a:lnSpc>
             </a:pPr>
+            <a:r>
+              <a:rPr sz="919" b="1">
+                <a:solidFill>
+                  <a:srgbClr val="004B2B"/>
+                </a:solidFill>
+                <a:latin typeface="Microsoft JhengHei"/>
+              </a:rPr>
+              <a:t>兩職合一 (兼任)</a:t>
+            </a:r>
           </a:p>
         </p:txBody>
       </p:sp>
@@ -6851,6 +6914,15 @@
                 <a:spcPct val="114000"/>
               </a:lnSpc>
             </a:pPr>
+            <a:r>
+              <a:rPr sz="880" b="0">
+                <a:solidFill>
+                  <a:srgbClr val="1A2E23"/>
+                </a:solidFill>
+                <a:latin typeface="Microsoft JhengHei"/>
+              </a:rPr>
+              <a:t>【適用情境】：創業期、動盪轉型期、需強人快速決策時</a:t>
+            </a:r>
           </a:p>
         </p:txBody>
       </p:sp>
@@ -6965,6 +7037,15 @@
                 <a:spcPct val="114000"/>
               </a:lnSpc>
             </a:pPr>
+            <a:r>
+              <a:rPr sz="880" b="0">
+                <a:solidFill>
+                  <a:srgbClr val="1A2E23"/>
+                </a:solidFill>
+                <a:latin typeface="Microsoft JhengHei"/>
+              </a:rPr>
+              <a:t>【核心風險】：自己當裁判又當球員，監督機制形同虛設</a:t>
+            </a:r>
           </a:p>
         </p:txBody>
       </p:sp>
@@ -7040,6 +7121,15 @@
                 <a:spcPct val="118000"/>
               </a:lnSpc>
             </a:pPr>
+            <a:r>
+              <a:rPr sz="919" b="1">
+                <a:solidFill>
+                  <a:srgbClr val="004B2B"/>
+                </a:solidFill>
+                <a:latin typeface="Microsoft JhengHei"/>
+              </a:rPr>
+              <a:t>兩職分離 (分設)</a:t>
+            </a:r>
           </a:p>
         </p:txBody>
       </p:sp>
@@ -7115,6 +7205,15 @@
                 <a:spcPct val="114000"/>
               </a:lnSpc>
             </a:pPr>
+            <a:r>
+              <a:rPr sz="880" b="0">
+                <a:solidFill>
+                  <a:srgbClr val="1A2E23"/>
+                </a:solidFill>
+                <a:latin typeface="Microsoft JhengHei"/>
+              </a:rPr>
+              <a:t>【適用情境】：成熟穩定期、大型公眾公司，強化對管理層之制衡</a:t>
+            </a:r>
           </a:p>
         </p:txBody>
       </p:sp>
@@ -7229,6 +7328,15 @@
                 <a:spcPct val="114000"/>
               </a:lnSpc>
             </a:pPr>
+            <a:r>
+              <a:rPr sz="880" b="0">
+                <a:solidFill>
+                  <a:srgbClr val="1A2E23"/>
+                </a:solidFill>
+                <a:latin typeface="Microsoft JhengHei"/>
+              </a:rPr>
+              <a:t>【核心風險】：易出現「一山不容二虎」雙頭馬車內耗，降低決策效率</a:t>
+            </a:r>
           </a:p>
         </p:txBody>
       </p:sp>
@@ -8199,11 +8307,11 @@
             <a:avLst/>
           </a:prstGeom>
           <a:solidFill>
-            <a:srgbClr val="FFFFFF"/>
+            <a:srgbClr val="F4F6F9"/>
           </a:solidFill>
-          <a:ln w="12700">
+          <a:ln w="19050">
             <a:solidFill>
-              <a:srgbClr val="CBD5E1"/>
+              <a:srgbClr val="0077C8"/>
             </a:solidFill>
           </a:ln>
         </p:spPr>
@@ -8244,7 +8352,7 @@
             <a:avLst/>
           </a:prstGeom>
           <a:solidFill>
-            <a:srgbClr val="051C2C"/>
+            <a:srgbClr val="0077C8"/>
           </a:solidFill>
           <a:ln>
             <a:noFill/>
@@ -8338,6 +8446,38 @@
                 <a:spcPct val="118000"/>
               </a:lnSpc>
             </a:pPr>
+            <a:r>
+              <a:rPr sz="930" b="0">
+                <a:solidFill>
+                  <a:srgbClr val="1A202C"/>
+                </a:solidFill>
+                <a:latin typeface="Microsoft JhengHei"/>
+              </a:rPr>
+              <a:t>▪ ③ 亞當・斯密洞見： 「管理別人的錢，很難像管理自己的錢那樣盡心盡力」——目標不一致＋資訊不對稱導致偷懶、在職消費或利益輸送</a:t>
+            </a:r>
+          </a:p>
+          <a:p>
+            <a:pPr algn="l">
+              <a:lnSpc>
+                <a:spcPct val="118000"/>
+              </a:lnSpc>
+            </a:pPr>
+          </a:p>
+          <a:p>
+            <a:pPr algn="l">
+              <a:lnSpc>
+                <a:spcPct val="118000"/>
+              </a:lnSpc>
+            </a:pPr>
+            <a:r>
+              <a:rPr sz="930" b="0">
+                <a:solidFill>
+                  <a:srgbClr val="1A202C"/>
+                </a:solidFill>
+                <a:latin typeface="Microsoft JhengHei"/>
+              </a:rPr>
+              <a:t>▪ ③ 內部人控制： 當大股東缺位或受困（如黃光裕入獄），經理人利用經營實權架空原股東</a:t>
+            </a:r>
           </a:p>
         </p:txBody>
       </p:sp>
@@ -8495,6 +8635,38 @@
                 <a:spcPct val="118000"/>
               </a:lnSpc>
             </a:pPr>
+            <a:r>
+              <a:rPr sz="930" b="0">
+                <a:solidFill>
+                  <a:srgbClr val="1A202C"/>
+                </a:solidFill>
+                <a:latin typeface="Microsoft JhengHei"/>
+              </a:rPr>
+              <a:t>▪ ③ 心理所有權 (Psychological Ownership)： 經理人傾注心血拯救公司後，在心理上覺得「這家公司是我的」，進而抗拒真正老闆（大股東）的干預</a:t>
+            </a:r>
+          </a:p>
+          <a:p>
+            <a:pPr algn="l">
+              <a:lnSpc>
+                <a:spcPct val="118000"/>
+              </a:lnSpc>
+            </a:pPr>
+          </a:p>
+          <a:p>
+            <a:pPr algn="l">
+              <a:lnSpc>
+                <a:spcPct val="118000"/>
+              </a:lnSpc>
+            </a:pPr>
+            <a:r>
+              <a:rPr sz="930" b="0">
+                <a:solidFill>
+                  <a:srgbClr val="1A202C"/>
+                </a:solidFill>
+                <a:latin typeface="Microsoft JhengHei"/>
+              </a:rPr>
+              <a:t>▪ ③ 經理治理三大處方： 1. 【監控機制】（沿用第二模組內外部防線） 2. 【選人機制】（第18講職業化標準） 3. 【激勵機制】（第19-20講薪酬與股權）</a:t>
+            </a:r>
           </a:p>
         </p:txBody>
       </p:sp>
@@ -8575,7 +8747,7 @@
                 </a:solidFill>
                 <a:latin typeface="Microsoft JhengHei"/>
               </a:rPr>
-              <a:t>🎯 結合型核心綜效：</a:t>
+              <a:t>🎯 結合型核心綜效：① 頂層結論：經理與老闆掐架的兩大病灶 ＝ 傳統委託代理衝突 ＋ 過高心理所有權越界</a:t>
             </a:r>
           </a:p>
         </p:txBody>
@@ -11281,7 +11453,7 @@
                 </a:solidFill>
                 <a:latin typeface="Microsoft JhengHei"/>
               </a:rPr>
-              <a:t>模式 A</a:t>
+              <a:t>② 流派 A：股東至上主義 (Shareholder Primacy)</a:t>
             </a:r>
           </a:p>
         </p:txBody>
@@ -11402,7 +11574,7 @@
                 </a:solidFill>
                 <a:latin typeface="Microsoft JhengHei"/>
               </a:rPr>
-              <a:t>模式 B</a:t>
+              <a:t>② 流派 B：利害關係人理論 (Stakeholder Theory)</a:t>
             </a:r>
           </a:p>
         </p:txBody>
@@ -11479,6 +11651,15 @@
                 <a:spcPct val="118000"/>
               </a:lnSpc>
             </a:pPr>
+            <a:r>
+              <a:rPr sz="919" b="1">
+                <a:solidFill>
+                  <a:srgbClr val="004B2B"/>
+                </a:solidFill>
+                <a:latin typeface="Microsoft JhengHei"/>
+              </a:rPr>
+              <a:t>核心主張</a:t>
+            </a:r>
           </a:p>
         </p:txBody>
       </p:sp>
@@ -11554,6 +11735,15 @@
                 <a:spcPct val="114000"/>
               </a:lnSpc>
             </a:pPr>
+            <a:r>
+              <a:rPr sz="880" b="0">
+                <a:solidFill>
+                  <a:srgbClr val="1A2E23"/>
+                </a:solidFill>
+                <a:latin typeface="Microsoft JhengHei"/>
+              </a:rPr>
+              <a:t>③ 公司屬於股東，經理人的唯一天職就是「為股東創造最大利潤與股價回報」（傅利曼 Milton Friedman）</a:t>
+            </a:r>
           </a:p>
         </p:txBody>
       </p:sp>
@@ -11668,6 +11858,15 @@
                 <a:spcPct val="114000"/>
               </a:lnSpc>
             </a:pPr>
+            <a:r>
+              <a:rPr sz="880" b="0">
+                <a:solidFill>
+                  <a:srgbClr val="1A2E23"/>
+                </a:solidFill>
+                <a:latin typeface="Microsoft JhengHei"/>
+              </a:rPr>
+              <a:t>③ 公司需對股東、員工、客戶、供應商、社區與環境等所有「利害關係人」共同負責（2019 美商業圓桌宣言）</a:t>
+            </a:r>
           </a:p>
         </p:txBody>
       </p:sp>
@@ -11743,6 +11942,15 @@
                 <a:spcPct val="118000"/>
               </a:lnSpc>
             </a:pPr>
+            <a:r>
+              <a:rPr sz="919" b="1">
+                <a:solidFill>
+                  <a:srgbClr val="004B2B"/>
+                </a:solidFill>
+                <a:latin typeface="Microsoft JhengHei"/>
+              </a:rPr>
+              <a:t>經典判例／事件</a:t>
+            </a:r>
           </a:p>
         </p:txBody>
       </p:sp>
@@ -11818,6 +12026,15 @@
                 <a:spcPct val="114000"/>
               </a:lnSpc>
             </a:pPr>
+            <a:r>
+              <a:rPr sz="880" b="0">
+                <a:solidFill>
+                  <a:srgbClr val="1A2E23"/>
+                </a:solidFill>
+                <a:latin typeface="Microsoft JhengHei"/>
+              </a:rPr>
+              <a:t>1919 年【道奇兄弟訴福特案】：福特想停發特別股息去降車價、給工人加薪，法院判福特敗訴，宣示「公司首要目的是為股東賺錢」</a:t>
+            </a:r>
           </a:p>
         </p:txBody>
       </p:sp>
@@ -11932,6 +12149,15 @@
                 <a:spcPct val="114000"/>
               </a:lnSpc>
             </a:pPr>
+            <a:r>
+              <a:rPr sz="880" b="0">
+                <a:solidFill>
+                  <a:srgbClr val="1A2E23"/>
+                </a:solidFill>
+                <a:latin typeface="Microsoft JhengHei"/>
+              </a:rPr>
+              <a:t>近年 ESG 浪潮與德日治理模式：批評華爾街「股東至上」導致企業砍研發、裁員工、回購股票炒短線</a:t>
+            </a:r>
           </a:p>
         </p:txBody>
       </p:sp>
@@ -12007,6 +12233,15 @@
                 <a:spcPct val="118000"/>
               </a:lnSpc>
             </a:pPr>
+            <a:r>
+              <a:rPr sz="919" b="1">
+                <a:solidFill>
+                  <a:srgbClr val="004B2B"/>
+                </a:solidFill>
+                <a:latin typeface="Microsoft JhengHei"/>
+              </a:rPr>
+              <a:t>致命缺陷</a:t>
+            </a:r>
           </a:p>
         </p:txBody>
       </p:sp>
@@ -12082,6 +12317,15 @@
                 <a:spcPct val="114000"/>
               </a:lnSpc>
             </a:pPr>
+            <a:r>
+              <a:rPr sz="880" b="0">
+                <a:solidFill>
+                  <a:srgbClr val="1A2E23"/>
+                </a:solidFill>
+                <a:latin typeface="Microsoft JhengHei"/>
+              </a:rPr>
+              <a:t>容易誘發短期業績主義、忽視員工福祉、環境污染與產品安全外部性</a:t>
+            </a:r>
           </a:p>
         </p:txBody>
       </p:sp>
@@ -12196,6 +12440,15 @@
                 <a:spcPct val="114000"/>
               </a:lnSpc>
             </a:pPr>
+            <a:r>
+              <a:rPr sz="880" b="0">
+                <a:solidFill>
+                  <a:srgbClr val="1A2E23"/>
+                </a:solidFill>
+                <a:latin typeface="Microsoft JhengHei"/>
+              </a:rPr>
+              <a:t>【操作性死結】：當股東要利潤、員工要加薪、客戶要降價互相衝突時，經理人到底聽誰的？</a:t>
+            </a:r>
           </a:p>
         </p:txBody>
       </p:sp>
@@ -12271,6 +12524,15 @@
                 <a:spcPct val="118000"/>
               </a:lnSpc>
             </a:pPr>
+            <a:r>
+              <a:rPr sz="919" b="1">
+                <a:solidFill>
+                  <a:srgbClr val="004B2B"/>
+                </a:solidFill>
+                <a:latin typeface="Microsoft JhengHei"/>
+              </a:rPr>
+              <a:t>對經理人治理影響</a:t>
+            </a:r>
           </a:p>
         </p:txBody>
       </p:sp>
@@ -12346,6 +12608,15 @@
                 <a:spcPct val="114000"/>
               </a:lnSpc>
             </a:pPr>
+            <a:r>
+              <a:rPr sz="880" b="0">
+                <a:solidFill>
+                  <a:srgbClr val="1A2E23"/>
+                </a:solidFill>
+                <a:latin typeface="Microsoft JhengHei"/>
+              </a:rPr>
+              <a:t>考核指標極度清晰（ROE、淨利潤、股價），經理人無法找藉口推卸責任</a:t>
+            </a:r>
           </a:p>
         </p:txBody>
       </p:sp>
@@ -12460,6 +12731,15 @@
                 <a:spcPct val="114000"/>
               </a:lnSpc>
             </a:pPr>
+            <a:r>
+              <a:rPr sz="880" b="0">
+                <a:solidFill>
+                  <a:srgbClr val="1A2E23"/>
+                </a:solidFill>
+                <a:latin typeface="Microsoft JhengHei"/>
+              </a:rPr>
+              <a:t>一旦沒有單一主目標，經理人極易拿「我在照顧員工/社會」當作經營不善的擋箭牌！</a:t>
+            </a:r>
           </a:p>
         </p:txBody>
       </p:sp>
@@ -13576,7 +13856,7 @@
                 </a:solidFill>
                 <a:latin typeface="Microsoft JhengHei"/>
               </a:rPr>
-              <a:t>模式 A</a:t>
+              <a:t>② 制度設計：德國垂直二元制（監事會高高在上）</a:t>
             </a:r>
           </a:p>
         </p:txBody>
@@ -13697,7 +13977,7 @@
                 </a:solidFill>
                 <a:latin typeface="Microsoft JhengHei"/>
               </a:rPr>
-              <a:t>模式 B</a:t>
+              <a:t>② 現實失靈：德意志銀行危機暴露之三大治理病灶</a:t>
             </a:r>
           </a:p>
         </p:txBody>
@@ -13774,6 +14054,15 @@
                 <a:spcPct val="118000"/>
               </a:lnSpc>
             </a:pPr>
+            <a:r>
+              <a:rPr sz="919" b="1">
+                <a:solidFill>
+                  <a:srgbClr val="004B2B"/>
+                </a:solidFill>
+                <a:latin typeface="Microsoft JhengHei"/>
+              </a:rPr>
+              <a:t>組織位階與權力</a:t>
+            </a:r>
           </a:p>
         </p:txBody>
       </p:sp>
@@ -13849,6 +14138,15 @@
                 <a:spcPct val="114000"/>
               </a:lnSpc>
             </a:pPr>
+            <a:r>
+              <a:rPr sz="880" b="0">
+                <a:solidFill>
+                  <a:srgbClr val="1A2E23"/>
+                </a:solidFill>
+                <a:latin typeface="Microsoft JhengHei"/>
+              </a:rPr>
+              <a:t>③ 股東會選出【監事會（Aufsichtsrat）】，再由監事會任命並監督【管理董事會（Vorstand）】——監事會是董事會的頂頭上司！（對比：中/台監事會與董事會平行，無權開除董事）</a:t>
+            </a:r>
           </a:p>
         </p:txBody>
       </p:sp>
@@ -13963,6 +14261,15 @@
                 <a:spcPct val="114000"/>
               </a:lnSpc>
             </a:pPr>
+            <a:r>
+              <a:rPr sz="880" b="0">
+                <a:solidFill>
+                  <a:srgbClr val="1A2E23"/>
+                </a:solidFill>
+                <a:latin typeface="Microsoft JhengHei"/>
+              </a:rPr>
+              <a:t>③ 位階雖高，但德意志銀行監事會長期未能制止管理層瘋狂擴張高風險衍生品（名義本金一度高達德國 GDP 數十倍），導致連年巨虧、股價崩跌逾 90%</a:t>
+            </a:r>
           </a:p>
         </p:txBody>
       </p:sp>
@@ -14038,6 +14345,15 @@
                 <a:spcPct val="118000"/>
               </a:lnSpc>
             </a:pPr>
+            <a:r>
+              <a:rPr sz="919" b="1">
+                <a:solidFill>
+                  <a:srgbClr val="004B2B"/>
+                </a:solidFill>
+                <a:latin typeface="Microsoft JhengHei"/>
+              </a:rPr>
+              <a:t>人脈與交叉持股</a:t>
+            </a:r>
           </a:p>
         </p:txBody>
       </p:sp>
@@ -14113,6 +14429,15 @@
                 <a:spcPct val="114000"/>
               </a:lnSpc>
             </a:pPr>
+            <a:r>
+              <a:rPr sz="880" b="0">
+                <a:solidFill>
+                  <a:srgbClr val="1A2E23"/>
+                </a:solidFill>
+                <a:latin typeface="Microsoft JhengHei"/>
+              </a:rPr>
+              <a:t>德國傳統主銀行制度與企業間交叉持股，提供長期穩定資本、免受華爾街短期干擾</a:t>
+            </a:r>
           </a:p>
         </p:txBody>
       </p:sp>
@@ -14227,6 +14552,15 @@
                 <a:spcPct val="114000"/>
               </a:lnSpc>
             </a:pPr>
+            <a:r>
+              <a:rPr sz="880" b="0">
+                <a:solidFill>
+                  <a:srgbClr val="1A2E23"/>
+                </a:solidFill>
+                <a:latin typeface="Microsoft JhengHei"/>
+              </a:rPr>
+              <a:t>形成封閉的「德國俱樂部（老男孩網路）」——你當我監事、我當你董事，熟人關係摧毀了監督的獨立性</a:t>
+            </a:r>
           </a:p>
         </p:txBody>
       </p:sp>
@@ -14302,6 +14636,15 @@
                 <a:spcPct val="118000"/>
               </a:lnSpc>
             </a:pPr>
+            <a:r>
+              <a:rPr sz="919" b="1">
+                <a:solidFill>
+                  <a:srgbClr val="004B2B"/>
+                </a:solidFill>
+                <a:latin typeface="Microsoft JhengHei"/>
+              </a:rPr>
+              <a:t>旋轉門與獨立性</a:t>
+            </a:r>
           </a:p>
         </p:txBody>
       </p:sp>
@@ -14377,6 +14720,15 @@
                 <a:spcPct val="114000"/>
               </a:lnSpc>
             </a:pPr>
+            <a:r>
+              <a:rPr sz="880" b="0">
+                <a:solidFill>
+                  <a:srgbClr val="1A2E23"/>
+                </a:solidFill>
+                <a:latin typeface="Microsoft JhengHei"/>
+              </a:rPr>
+              <a:t>期望由最懂業務的前任高管進入監事會把關</a:t>
+            </a:r>
           </a:p>
         </p:txBody>
       </p:sp>
@@ -14491,6 +14843,15 @@
                 <a:spcPct val="114000"/>
               </a:lnSpc>
             </a:pPr>
+            <a:r>
+              <a:rPr sz="880" b="0">
+                <a:solidFill>
+                  <a:srgbClr val="1A2E23"/>
+                </a:solidFill>
+                <a:latin typeface="Microsoft JhengHei"/>
+              </a:rPr>
+              <a:t>前任 CEO 卸任後直接轉任監事會主席，根本不願否定自己當年的戰略與提拔的親信（後修法強制要求 2 年冷卻期）</a:t>
+            </a:r>
           </a:p>
         </p:txBody>
       </p:sp>
@@ -14566,6 +14927,15 @@
                 <a:spcPct val="118000"/>
               </a:lnSpc>
             </a:pPr>
+            <a:r>
+              <a:rPr sz="919" b="1">
+                <a:solidFill>
+                  <a:srgbClr val="004B2B"/>
+                </a:solidFill>
+                <a:latin typeface="Microsoft JhengHei"/>
+              </a:rPr>
+              <a:t>風控與資訊屏蔽</a:t>
+            </a:r>
           </a:p>
         </p:txBody>
       </p:sp>
@@ -14641,6 +15011,15 @@
                 <a:spcPct val="114000"/>
               </a:lnSpc>
             </a:pPr>
+            <a:r>
+              <a:rPr sz="880" b="0">
+                <a:solidFill>
+                  <a:srgbClr val="1A2E23"/>
+                </a:solidFill>
+                <a:latin typeface="Microsoft JhengHei"/>
+              </a:rPr>
+              <a:t>監事會下設風險委員會負責重大風控監督</a:t>
+            </a:r>
           </a:p>
         </p:txBody>
       </p:sp>
@@ -14755,6 +15134,15 @@
                 <a:spcPct val="114000"/>
               </a:lnSpc>
             </a:pPr>
+            <a:r>
+              <a:rPr sz="880" b="0">
+                <a:solidFill>
+                  <a:srgbClr val="1A2E23"/>
+                </a:solidFill>
+                <a:latin typeface="Microsoft JhengHei"/>
+              </a:rPr>
+              <a:t>管理層刻意邊緣化風控官、甚至將風控部門外遷，監事會因兼職時間有限與專業不足而淪為擺設</a:t>
+            </a:r>
           </a:p>
         </p:txBody>
       </p:sp>
@@ -16158,6 +16546,15 @@
                 <a:spcPct val="118000"/>
               </a:lnSpc>
             </a:pPr>
+            <a:r>
+              <a:rPr sz="950" b="1">
+                <a:solidFill>
+                  <a:srgbClr val="051C2C"/>
+                </a:solidFill>
+                <a:latin typeface="Microsoft JhengHei"/>
+              </a:rPr>
+              <a:t>③ 制度機制 與運作細節</a:t>
+            </a:r>
           </a:p>
         </p:txBody>
       </p:sp>
@@ -16485,6 +16882,15 @@
                 <a:spcPct val="118000"/>
               </a:lnSpc>
             </a:pPr>
+            <a:r>
+              <a:rPr sz="950" b="1">
+                <a:solidFill>
+                  <a:srgbClr val="051C2C"/>
+                </a:solidFill>
+                <a:latin typeface="Microsoft JhengHei"/>
+              </a:rPr>
+              <a:t>③ 治理躍遷 與核心成效</a:t>
+            </a:r>
           </a:p>
         </p:txBody>
       </p:sp>
@@ -17742,7 +18148,7 @@
                 </a:solidFill>
                 <a:latin typeface="Microsoft JhengHei"/>
               </a:rPr>
-              <a:t>縱軸維度</a:t>
+              <a:t>資金與抗風險需求（低 ➔ 高）</a:t>
             </a:r>
           </a:p>
         </p:txBody>
@@ -17781,7 +18187,7 @@
                 </a:solidFill>
                 <a:latin typeface="Microsoft JhengHei"/>
               </a:rPr>
-              <a:t>橫軸維度  ▶</a:t>
+              <a:t>治理約束與控制權稀釋容忍度（低 ➔ 高）  ▶</a:t>
             </a:r>
           </a:p>
         </p:txBody>
@@ -17908,7 +18314,7 @@
                 </a:solidFill>
                 <a:latin typeface="Microsoft JhengHei"/>
               </a:rPr>
-              <a:t>象限 1</a:t>
+              <a:t>左上象限 (高Y / 低X)</a:t>
             </a:r>
           </a:p>
         </p:txBody>
@@ -18129,7 +18535,7 @@
                 </a:solidFill>
                 <a:latin typeface="Microsoft JhengHei"/>
               </a:rPr>
-              <a:t>象限 2</a:t>
+              <a:t>右上象限 (高Y / 高X)</a:t>
             </a:r>
           </a:p>
         </p:txBody>
@@ -18350,7 +18756,7 @@
                 </a:solidFill>
                 <a:latin typeface="Microsoft JhengHei"/>
               </a:rPr>
-              <a:t>象限 3</a:t>
+              <a:t>左下象限 (低Y / 低X)</a:t>
             </a:r>
           </a:p>
         </p:txBody>
@@ -18571,7 +18977,7 @@
                 </a:solidFill>
                 <a:latin typeface="Microsoft JhengHei"/>
               </a:rPr>
-              <a:t>象限 4</a:t>
+              <a:t>右下象限 (低Y / 高X)</a:t>
             </a:r>
           </a:p>
         </p:txBody>
@@ -22323,11 +22729,11 @@
             <a:avLst/>
           </a:prstGeom>
           <a:solidFill>
-            <a:srgbClr val="FFFFFF"/>
+            <a:srgbClr val="F4F6F9"/>
           </a:solidFill>
-          <a:ln w="12700">
+          <a:ln w="19050">
             <a:solidFill>
-              <a:srgbClr val="CBD5E1"/>
+              <a:srgbClr val="0077C8"/>
             </a:solidFill>
           </a:ln>
         </p:spPr>
@@ -22368,7 +22774,7 @@
             <a:avLst/>
           </a:prstGeom>
           <a:solidFill>
-            <a:srgbClr val="051C2C"/>
+            <a:srgbClr val="0077C8"/>
           </a:solidFill>
           <a:ln>
             <a:noFill/>
@@ -22462,6 +22868,38 @@
                 <a:spcPct val="118000"/>
               </a:lnSpc>
             </a:pPr>
+            <a:r>
+              <a:rPr sz="930" b="0">
+                <a:solidFill>
+                  <a:srgbClr val="1A202C"/>
+                </a:solidFill>
+                <a:latin typeface="Microsoft JhengHei"/>
+              </a:rPr>
+              <a:t>▪ ③ 事實 A（兩類人）： 聚焦【股東】與【高層經理人】之間的委託代理與控制關係</a:t>
+            </a:r>
+          </a:p>
+          <a:p>
+            <a:pPr algn="l">
+              <a:lnSpc>
+                <a:spcPct val="118000"/>
+              </a:lnSpc>
+            </a:pPr>
+          </a:p>
+          <a:p>
+            <a:pPr algn="l">
+              <a:lnSpc>
+                <a:spcPct val="118000"/>
+              </a:lnSpc>
+            </a:pPr>
+            <a:r>
+              <a:rPr sz="930" b="0">
+                <a:solidFill>
+                  <a:srgbClr val="1A202C"/>
+                </a:solidFill>
+                <a:latin typeface="Microsoft JhengHei"/>
+              </a:rPr>
+              <a:t>▪ ③ 事實 B（兩件事）： 確立【權力如何配置（誰說了算）】與【利益如何分配（怎麼分錢）】</a:t>
+            </a:r>
           </a:p>
         </p:txBody>
       </p:sp>
@@ -22619,6 +23057,38 @@
                 <a:spcPct val="118000"/>
               </a:lnSpc>
             </a:pPr>
+            <a:r>
+              <a:rPr sz="930" b="0">
+                <a:solidFill>
+                  <a:srgbClr val="1A202C"/>
+                </a:solidFill>
+                <a:latin typeface="Microsoft JhengHei"/>
+              </a:rPr>
+              <a:t>▪ ③ 事實 C（聯想案例）： 柳傳志身為國企背景職業經理人，受股東回報與資本市場短期壓力約束</a:t>
+            </a:r>
+          </a:p>
+          <a:p>
+            <a:pPr algn="l">
+              <a:lnSpc>
+                <a:spcPct val="118000"/>
+              </a:lnSpc>
+            </a:pPr>
+          </a:p>
+          <a:p>
+            <a:pPr algn="l">
+              <a:lnSpc>
+                <a:spcPct val="118000"/>
+              </a:lnSpc>
+            </a:pPr>
+            <a:r>
+              <a:rPr sz="930" b="0">
+                <a:solidFill>
+                  <a:srgbClr val="1A202C"/>
+                </a:solidFill>
+                <a:latin typeface="Microsoft JhengHei"/>
+              </a:rPr>
+              <a:t>▪ ③ 事實 D（華為案例）： 任正非身為民企創始股東，擁有自主投入晶片長線研發並承擔虧損的權限</a:t>
+            </a:r>
           </a:p>
         </p:txBody>
       </p:sp>
@@ -22699,7 +23169,7 @@
                 </a:solidFill>
                 <a:latin typeface="Microsoft JhengHei"/>
               </a:rPr>
-              <a:t>🎯 結合型核心綜效：</a:t>
+              <a:t>🎯 結合型核心綜效：① 頂層結論：公司治理（樹根）決定管理（樹幹）能否結出長期業績（花果）</a:t>
             </a:r>
           </a:p>
         </p:txBody>
@@ -23817,7 +24287,7 @@
                 </a:solidFill>
                 <a:latin typeface="Microsoft JhengHei"/>
               </a:rPr>
-              <a:t>模式 A</a:t>
+              <a:t>② 見解 A：古典企業（個人獨資／合夥企業）</a:t>
             </a:r>
           </a:p>
         </p:txBody>
@@ -23938,7 +24408,7 @@
                 </a:solidFill>
                 <a:latin typeface="Microsoft JhengHei"/>
               </a:rPr>
-              <a:t>模式 B</a:t>
+              <a:t>② 見解 B：現代公司（有限責任／股份有限公司）</a:t>
             </a:r>
           </a:p>
         </p:txBody>
@@ -24015,6 +24485,15 @@
                 <a:spcPct val="118000"/>
               </a:lnSpc>
             </a:pPr>
+            <a:r>
+              <a:rPr sz="919" b="1">
+                <a:solidFill>
+                  <a:srgbClr val="004B2B"/>
+                </a:solidFill>
+                <a:latin typeface="Microsoft JhengHei"/>
+              </a:rPr>
+              <a:t>法律身分</a:t>
+            </a:r>
           </a:p>
         </p:txBody>
       </p:sp>
@@ -24090,6 +24569,15 @@
                 <a:spcPct val="114000"/>
               </a:lnSpc>
             </a:pPr>
+            <a:r>
+              <a:rPr sz="880" b="0">
+                <a:solidFill>
+                  <a:srgbClr val="1A2E23"/>
+                </a:solidFill>
+                <a:latin typeface="Microsoft JhengHei"/>
+              </a:rPr>
+              <a:t>③ 自然人企業：企業與老闆個人沒有法律人格邊界</a:t>
+            </a:r>
           </a:p>
         </p:txBody>
       </p:sp>
@@ -24204,6 +24692,15 @@
                 <a:spcPct val="114000"/>
               </a:lnSpc>
             </a:pPr>
+            <a:r>
+              <a:rPr sz="880" b="0">
+                <a:solidFill>
+                  <a:srgbClr val="1A2E23"/>
+                </a:solidFill>
+                <a:latin typeface="Microsoft JhengHei"/>
+              </a:rPr>
+              <a:t>③ 法人企業（Corporation）：法律上獨立的「人」，擁有獨立法人財產權</a:t>
+            </a:r>
           </a:p>
         </p:txBody>
       </p:sp>
@@ -24279,6 +24776,15 @@
                 <a:spcPct val="118000"/>
               </a:lnSpc>
             </a:pPr>
+            <a:r>
+              <a:rPr sz="919" b="1">
+                <a:solidFill>
+                  <a:srgbClr val="004B2B"/>
+                </a:solidFill>
+                <a:latin typeface="Microsoft JhengHei"/>
+              </a:rPr>
+              <a:t>債務責任</a:t>
+            </a:r>
           </a:p>
         </p:txBody>
       </p:sp>
@@ -24354,6 +24860,15 @@
                 <a:spcPct val="114000"/>
               </a:lnSpc>
             </a:pPr>
+            <a:r>
+              <a:rPr sz="880" b="0">
+                <a:solidFill>
+                  <a:srgbClr val="1A2E23"/>
+                </a:solidFill>
+                <a:latin typeface="Microsoft JhengHei"/>
+              </a:rPr>
+              <a:t>無限連帶責任：胡雪岩阜康銀號倒閉，須抄家傾家蕩產抵債</a:t>
+            </a:r>
           </a:p>
         </p:txBody>
       </p:sp>
@@ -24468,6 +24983,15 @@
                 <a:spcPct val="114000"/>
               </a:lnSpc>
             </a:pPr>
+            <a:r>
+              <a:rPr sz="880" b="0">
+                <a:solidFill>
+                  <a:srgbClr val="1A2E23"/>
+                </a:solidFill>
+                <a:latin typeface="Microsoft JhengHei"/>
+              </a:rPr>
+              <a:t>有限責任制度：股東僅以「出資額」為限承擔債務，個人資產受保護</a:t>
+            </a:r>
           </a:p>
         </p:txBody>
       </p:sp>
@@ -24543,6 +25067,15 @@
                 <a:spcPct val="118000"/>
               </a:lnSpc>
             </a:pPr>
+            <a:r>
+              <a:rPr sz="919" b="1">
+                <a:solidFill>
+                  <a:srgbClr val="004B2B"/>
+                </a:solidFill>
+                <a:latin typeface="Microsoft JhengHei"/>
+              </a:rPr>
+              <a:t>財產邊界</a:t>
+            </a:r>
           </a:p>
         </p:txBody>
       </p:sp>
@@ -24618,6 +25151,15 @@
                 <a:spcPct val="114000"/>
               </a:lnSpc>
             </a:pPr>
+            <a:r>
+              <a:rPr sz="880" b="0">
+                <a:solidFill>
+                  <a:srgbClr val="1A2E23"/>
+                </a:solidFill>
+                <a:latin typeface="Microsoft JhengHei"/>
+              </a:rPr>
+              <a:t>老闆可隨意取用店內財物（如《金瓶梅》西門慶把當鋪屏風搬回家）</a:t>
+            </a:r>
           </a:p>
         </p:txBody>
       </p:sp>
@@ -24732,6 +25274,15 @@
                 <a:spcPct val="114000"/>
               </a:lnSpc>
             </a:pPr>
+            <a:r>
+              <a:rPr sz="880" b="0">
+                <a:solidFill>
+                  <a:srgbClr val="1A2E23"/>
+                </a:solidFill>
+                <a:latin typeface="Microsoft JhengHei"/>
+              </a:rPr>
+              <a:t>股東私拿公司錢屬犯罪（如創維創辦人黃宏生挪用資金遭判刑）</a:t>
+            </a:r>
           </a:p>
         </p:txBody>
       </p:sp>
@@ -24807,6 +25358,15 @@
                 <a:spcPct val="118000"/>
               </a:lnSpc>
             </a:pPr>
+            <a:r>
+              <a:rPr sz="919" b="1">
+                <a:solidFill>
+                  <a:srgbClr val="004B2B"/>
+                </a:solidFill>
+                <a:latin typeface="Microsoft JhengHei"/>
+              </a:rPr>
+              <a:t>集資與壽命</a:t>
+            </a:r>
           </a:p>
         </p:txBody>
       </p:sp>
@@ -24882,6 +25442,15 @@
                 <a:spcPct val="114000"/>
               </a:lnSpc>
             </a:pPr>
+            <a:r>
+              <a:rPr sz="880" b="0">
+                <a:solidFill>
+                  <a:srgbClr val="1A2E23"/>
+                </a:solidFill>
+                <a:latin typeface="Microsoft JhengHei"/>
+              </a:rPr>
+              <a:t>親友熟人小規模集資；自然人死亡或退夥即易中斷</a:t>
+            </a:r>
           </a:p>
         </p:txBody>
       </p:sp>
@@ -24996,6 +25565,15 @@
                 <a:spcPct val="114000"/>
               </a:lnSpc>
             </a:pPr>
+            <a:r>
+              <a:rPr sz="880" b="0">
+                <a:solidFill>
+                  <a:srgbClr val="1A2E23"/>
+                </a:solidFill>
+                <a:latin typeface="Microsoft JhengHei"/>
+              </a:rPr>
+              <a:t>陌生人放心集聚巨額資本（如東印度公司、修鐵路）；股份自由轉讓可永續經營</a:t>
+            </a:r>
           </a:p>
         </p:txBody>
       </p:sp>
@@ -26073,7 +26651,7 @@
                 </a:solidFill>
                 <a:latin typeface="Microsoft JhengHei"/>
               </a:rPr>
-              <a:t>STEP 1</a:t>
+              <a:t>階段 1</a:t>
             </a:r>
           </a:p>
         </p:txBody>
@@ -26105,6 +26683,15 @@
                 <a:spcPct val="118000"/>
               </a:lnSpc>
             </a:pPr>
+            <a:r>
+              <a:rPr sz="1080" b="1">
+                <a:solidFill>
+                  <a:srgbClr val="2D1054"/>
+                </a:solidFill>
+                <a:latin typeface="Microsoft JhengHei"/>
+              </a:rPr>
+              <a:t>個人獨資／初創期</a:t>
+            </a:r>
           </a:p>
         </p:txBody>
       </p:sp>
@@ -26135,6 +26722,15 @@
                 <a:spcPct val="114000"/>
               </a:lnSpc>
             </a:pPr>
+            <a:r>
+              <a:rPr sz="919" b="0">
+                <a:solidFill>
+                  <a:srgbClr val="221633"/>
+                </a:solidFill>
+                <a:latin typeface="Microsoft JhengHei"/>
+              </a:rPr>
+              <a:t>信任基礎：100% 依賴對老闆個人的【人際信任】 ｜ 組織特徵：規模小、關係緊密、溝通成本極低 ｜ 治理提醒：切忌盲目照搬大企業繁瑣制度</a:t>
+            </a:r>
           </a:p>
         </p:txBody>
       </p:sp>
@@ -26260,7 +26856,7 @@
                 </a:solidFill>
                 <a:latin typeface="Microsoft JhengHei"/>
               </a:rPr>
-              <a:t>STEP 2</a:t>
+              <a:t>階段 2</a:t>
             </a:r>
           </a:p>
         </p:txBody>
@@ -26292,6 +26888,15 @@
                 <a:spcPct val="118000"/>
               </a:lnSpc>
             </a:pPr>
+            <a:r>
+              <a:rPr sz="1080" b="1">
+                <a:solidFill>
+                  <a:srgbClr val="2D1054"/>
+                </a:solidFill>
+                <a:latin typeface="Microsoft JhengHei"/>
+              </a:rPr>
+              <a:t>合夥／有限責任公司</a:t>
+            </a:r>
           </a:p>
         </p:txBody>
       </p:sp>
@@ -26322,6 +26927,15 @@
                 <a:spcPct val="114000"/>
               </a:lnSpc>
             </a:pPr>
+            <a:r>
+              <a:rPr sz="919" b="0">
+                <a:solidFill>
+                  <a:srgbClr val="221633"/>
+                </a:solidFill>
+                <a:latin typeface="Microsoft JhengHei"/>
+              </a:rPr>
+              <a:t>信任基礎：【人際信任為主 ＋ 制度信任為輔】 ｜ 組織特徵：股東限額（如 50 人內）、股權轉讓需過半股東同意（人合性） ｜ 治理痛點：德雲社用「江湖師徒制」管現代公司，導致曹雲金等骨幹出走</a:t>
+            </a:r>
           </a:p>
         </p:txBody>
       </p:sp>
@@ -26340,11 +26954,11 @@
             <a:avLst/>
           </a:prstGeom>
           <a:solidFill>
-            <a:srgbClr val="FFFFFF"/>
+            <a:srgbClr val="F8F5FC"/>
           </a:solidFill>
-          <a:ln w="12700">
+          <a:ln w="19050">
             <a:solidFill>
-              <a:srgbClr val="D8CCE8"/>
+              <a:srgbClr val="A100FF"/>
             </a:solidFill>
           </a:ln>
         </p:spPr>
@@ -26385,7 +26999,7 @@
             <a:avLst/>
           </a:prstGeom>
           <a:solidFill>
-            <a:srgbClr val="2D1054"/>
+            <a:srgbClr val="A100FF"/>
           </a:solidFill>
           <a:ln>
             <a:noFill/>
@@ -26447,7 +27061,7 @@
                 </a:solidFill>
                 <a:latin typeface="Microsoft JhengHei"/>
               </a:rPr>
-              <a:t>STEP 3</a:t>
+              <a:t>階段 3</a:t>
             </a:r>
           </a:p>
         </p:txBody>
@@ -26479,6 +27093,15 @@
                 <a:spcPct val="118000"/>
               </a:lnSpc>
             </a:pPr>
+            <a:r>
+              <a:rPr sz="1080" b="1">
+                <a:solidFill>
+                  <a:srgbClr val="A100FF"/>
+                </a:solidFill>
+                <a:latin typeface="Microsoft JhengHei"/>
+              </a:rPr>
+              <a:t>股份有限公司／上市企業</a:t>
+            </a:r>
           </a:p>
         </p:txBody>
       </p:sp>
@@ -26509,6 +27132,15 @@
                 <a:spcPct val="114000"/>
               </a:lnSpc>
             </a:pPr>
+            <a:r>
+              <a:rPr sz="919" b="0">
+                <a:solidFill>
+                  <a:srgbClr val="221633"/>
+                </a:solidFill>
+                <a:latin typeface="Microsoft JhengHei"/>
+              </a:rPr>
+              <a:t>信任基礎：高度依賴【制度信任】（法律、章程、資訊披露） ｜ 組織特徵：成千上萬陌生股東（資合性）、同股同權、自由買賣 ｜ 制度四要素：公平性、確定性、普遍性、可執行性</a:t>
+            </a:r>
           </a:p>
         </p:txBody>
       </p:sp>
@@ -27479,11 +28111,11 @@
             <a:avLst/>
           </a:prstGeom>
           <a:solidFill>
-            <a:srgbClr val="FFFFFF"/>
+            <a:srgbClr val="F8F5FC"/>
           </a:solidFill>
-          <a:ln w="12700">
+          <a:ln w="19050">
             <a:solidFill>
-              <a:srgbClr val="D8CCE8"/>
+              <a:srgbClr val="A100FF"/>
             </a:solidFill>
           </a:ln>
         </p:spPr>
@@ -27524,7 +28156,7 @@
             <a:avLst/>
           </a:prstGeom>
           <a:solidFill>
-            <a:srgbClr val="2D1054"/>
+            <a:srgbClr val="A100FF"/>
           </a:solidFill>
           <a:ln>
             <a:noFill/>
@@ -27567,7 +28199,7 @@
             <a:avLst/>
           </a:prstGeom>
           <a:solidFill>
-            <a:srgbClr val="2D1054"/>
+            <a:srgbClr val="A100FF"/>
           </a:solidFill>
           <a:ln>
             <a:noFill/>
@@ -27629,7 +28261,7 @@
                 </a:solidFill>
                 <a:latin typeface="Microsoft JhengHei"/>
               </a:rPr>
-              <a:t>要點 1</a:t>
+              <a:t>核心支柱 1</a:t>
             </a:r>
           </a:p>
         </p:txBody>
@@ -27700,6 +28332,15 @@
                 <a:spcPct val="118000"/>
               </a:lnSpc>
             </a:pPr>
+            <a:r>
+              <a:rPr sz="950" b="0">
+                <a:solidFill>
+                  <a:srgbClr val="221633"/>
+                </a:solidFill>
+                <a:latin typeface="Microsoft JhengHei"/>
+              </a:rPr>
+              <a:t>【股權控制】：把握融資節奏，切忌早期賤賣過多股權；守住 67%、51% 或 34% 關鍵防線；【資源控制】：牢牢掌握核心技術、品牌商標、關鍵通路或客戶關係；實例：雷士照明吳長江曾遭投資人逼宮，憑藉全國經銷商力挺與核心供應鏈支持一度奪回主導權</a:t>
+            </a:r>
           </a:p>
         </p:txBody>
       </p:sp>
@@ -27868,7 +28509,7 @@
                 </a:solidFill>
                 <a:latin typeface="Microsoft JhengHei"/>
               </a:rPr>
-              <a:t>要點 2</a:t>
+              <a:t>核心支柱 2</a:t>
             </a:r>
           </a:p>
         </p:txBody>
@@ -27939,6 +28580,15 @@
                 <a:spcPct val="118000"/>
               </a:lnSpc>
             </a:pPr>
+            <a:r>
+              <a:rPr sz="950" b="0">
+                <a:solidFill>
+                  <a:srgbClr val="221633"/>
+                </a:solidFill>
+                <a:latin typeface="Microsoft JhengHei"/>
+              </a:rPr>
+              <a:t>【金字塔多層控股】：透過母公司層層控股子公司，以較小資金撬動底層公司超過 50% 表決權；【有限合夥架構 (GP/LP)】：創始人擔任普通合夥人（GP），只出極少資金卻握有 100% 執行與投票控制權；投資人與員工擔任有限合夥人（LP）只享分紅不干預決策</a:t>
+            </a:r>
           </a:p>
         </p:txBody>
       </p:sp>
@@ -28107,7 +28757,7 @@
                 </a:solidFill>
                 <a:latin typeface="Microsoft JhengHei"/>
               </a:rPr>
-              <a:t>要點 3</a:t>
+              <a:t>核心支柱 3</a:t>
             </a:r>
           </a:p>
         </p:txBody>
@@ -28178,6 +28828,15 @@
                 <a:spcPct val="118000"/>
               </a:lnSpc>
             </a:pPr>
+            <a:r>
+              <a:rPr sz="950" b="0">
+                <a:solidFill>
+                  <a:srgbClr val="221633"/>
+                </a:solidFill>
+                <a:latin typeface="Microsoft JhengHei"/>
+              </a:rPr>
+              <a:t>【一致行動人協議】：與共同創辦人簽約，約定投票時必須與主創始人保持一致；【表決權委託 (Proxy)】：小股東將投票權全權委託給創始人行使；【公司章程客製化】：在章程中設定董事提名權與反收購條款，絕不拿工商局公版章程直接填空</a:t>
+            </a:r>
           </a:p>
         </p:txBody>
       </p:sp>
@@ -29581,6 +30240,15 @@
                 <a:spcPct val="118000"/>
               </a:lnSpc>
             </a:pPr>
+            <a:r>
+              <a:rPr sz="950" b="1">
+                <a:solidFill>
+                  <a:srgbClr val="051C2C"/>
+                </a:solidFill>
+                <a:latin typeface="Microsoft JhengHei"/>
+              </a:rPr>
+              <a:t>③ 病徵表現 與經典案例</a:t>
+            </a:r>
           </a:p>
         </p:txBody>
       </p:sp>
@@ -29908,6 +30576,15 @@
                 <a:spcPct val="118000"/>
               </a:lnSpc>
             </a:pPr>
+            <a:r>
+              <a:rPr sz="950" b="1">
+                <a:solidFill>
+                  <a:srgbClr val="051C2C"/>
+                </a:solidFill>
+                <a:latin typeface="Microsoft JhengHei"/>
+              </a:rPr>
+              <a:t>③ 頂層治理 解方與轉型</a:t>
+            </a:r>
           </a:p>
         </p:txBody>
       </p:sp>
@@ -31130,11 +31807,11 @@
             <a:avLst/>
           </a:prstGeom>
           <a:solidFill>
-            <a:srgbClr val="FFFFFF"/>
+            <a:srgbClr val="F2F8F5"/>
           </a:solidFill>
-          <a:ln w="12700">
+          <a:ln w="19050">
             <a:solidFill>
-              <a:srgbClr val="C3DCCF"/>
+              <a:srgbClr val="177B57"/>
             </a:solidFill>
           </a:ln>
         </p:spPr>
@@ -31175,7 +31852,7 @@
             <a:avLst/>
           </a:prstGeom>
           <a:solidFill>
-            <a:srgbClr val="004B2B"/>
+            <a:srgbClr val="177B57"/>
           </a:solidFill>
           <a:ln>
             <a:noFill/>
@@ -31269,6 +31946,38 @@
                 <a:spcPct val="118000"/>
               </a:lnSpc>
             </a:pPr>
+            <a:r>
+              <a:rPr sz="930" b="0">
+                <a:solidFill>
+                  <a:srgbClr val="1A2E23"/>
+                </a:solidFill>
+                <a:latin typeface="Microsoft JhengHei"/>
+              </a:rPr>
+              <a:t>▪ ③ 華為標竿案例： 雖為非上市公司，自 2000 年起聘請 KPMG 審計並向全球公開年報與治理架構，化解歐美客戶對其背景的疑慮</a:t>
+            </a:r>
+          </a:p>
+          <a:p>
+            <a:pPr algn="l">
+              <a:lnSpc>
+                <a:spcPct val="118000"/>
+              </a:lnSpc>
+            </a:pPr>
+          </a:p>
+          <a:p>
+            <a:pPr algn="l">
+              <a:lnSpc>
+                <a:spcPct val="118000"/>
+              </a:lnSpc>
+            </a:pPr>
+            <a:r>
+              <a:rPr sz="930" b="0">
+                <a:solidFill>
+                  <a:srgbClr val="1A2E23"/>
+                </a:solidFill>
+                <a:latin typeface="Microsoft JhengHei"/>
+              </a:rPr>
+              <a:t>▪ ③ 員工激勵定錨： 引入外部知名投資機構或公開財報，能給公司公允估值，讓員工手上的股權激勵「看得見真實價值」</a:t>
+            </a:r>
           </a:p>
         </p:txBody>
       </p:sp>
@@ -31426,6 +32135,38 @@
                 <a:spcPct val="118000"/>
               </a:lnSpc>
             </a:pPr>
+            <a:r>
+              <a:rPr sz="930" b="0">
+                <a:solidFill>
+                  <a:srgbClr val="1A2E23"/>
+                </a:solidFill>
+                <a:latin typeface="Microsoft JhengHei"/>
+              </a:rPr>
+              <a:t>▪ ③ 權力自我約束： 當高管薪酬、關聯交易與重大投資必須攤在陽光下供股民、媒體與監管檢視時，大股東就不敢肆意妄為</a:t>
+            </a:r>
+          </a:p>
+          <a:p>
+            <a:pPr algn="l">
+              <a:lnSpc>
+                <a:spcPct val="118000"/>
+              </a:lnSpc>
+            </a:pPr>
+          </a:p>
+          <a:p>
+            <a:pPr algn="l">
+              <a:lnSpc>
+                <a:spcPct val="118000"/>
+              </a:lnSpc>
+            </a:pPr>
+            <a:r>
+              <a:rPr sz="930" b="0">
+                <a:solidFill>
+                  <a:srgbClr val="1A2E23"/>
+                </a:solidFill>
+                <a:latin typeface="Microsoft JhengHei"/>
+              </a:rPr>
+              <a:t>▪ ③ 上市的真正意義： 上市不只為了圈錢融資，更是企業主動戴上「透明化緊箍咒」、完成現代公司治理成人禮的過程</a:t>
+            </a:r>
           </a:p>
         </p:txBody>
       </p:sp>
@@ -31506,7 +32247,7 @@
                 </a:solidFill>
                 <a:latin typeface="Microsoft JhengHei"/>
               </a:rPr>
-              <a:t>🎯 結合型核心綜效：</a:t>
+              <a:t>🎯 結合型核心綜效：① 頂層結論：透明化溢價 (Transparency Premium) ＝ 對外贏得低成本信任 ＋ 對內形成權力防腐劑</a:t>
             </a:r>
           </a:p>
         </p:txBody>
@@ -32513,7 +33254,7 @@
                 </a:solidFill>
                 <a:latin typeface="Microsoft JhengHei"/>
               </a:rPr>
-              <a:t>縱軸維度</a:t>
+              <a:t>資金與抗風險需求（低 ➔ 高）</a:t>
             </a:r>
           </a:p>
         </p:txBody>
@@ -32552,7 +33293,7 @@
                 </a:solidFill>
                 <a:latin typeface="Microsoft JhengHei"/>
               </a:rPr>
-              <a:t>橫軸維度  ▶</a:t>
+              <a:t>治理約束與控制權稀釋容忍度（低 ➔ 高）  ▶</a:t>
             </a:r>
           </a:p>
         </p:txBody>
@@ -32679,7 +33420,7 @@
                 </a:solidFill>
                 <a:latin typeface="Microsoft JhengHei"/>
               </a:rPr>
-              <a:t>象限 1</a:t>
+              <a:t>左上象限 (高Y / 低X)</a:t>
             </a:r>
           </a:p>
         </p:txBody>
@@ -32900,7 +33641,7 @@
                 </a:solidFill>
                 <a:latin typeface="Microsoft JhengHei"/>
               </a:rPr>
-              <a:t>象限 2</a:t>
+              <a:t>右上象限 (高Y / 高X)</a:t>
             </a:r>
           </a:p>
         </p:txBody>
@@ -33121,7 +33862,7 @@
                 </a:solidFill>
                 <a:latin typeface="Microsoft JhengHei"/>
               </a:rPr>
-              <a:t>象限 3</a:t>
+              <a:t>左下象限 (低Y / 低X)</a:t>
             </a:r>
           </a:p>
         </p:txBody>
@@ -33342,7 +34083,7 @@
                 </a:solidFill>
                 <a:latin typeface="Microsoft JhengHei"/>
               </a:rPr>
-              <a:t>象限 4</a:t>
+              <a:t>右下象限 (低Y / 高X)</a:t>
             </a:r>
           </a:p>
         </p:txBody>

</xml_diff>